<commit_message>
Use the actual race portraits on the Four Ranks slide, not generic icons
Human: "why didn't you use the icon of isekai when use them" -- fair
catch. The convention already ships official portrait art
(.isekai/portraits/rimuru.png, elf.png, orc.png, slime.png) used
throughout tempest.js and the world's own docs; slide 3 was using
hand-drawn generic icons (crown, speech bubble, shield, database)
instead of that established identity. Swapped them in. The other
icons (lightbulb/Minds, robot/Bodies, eye/Perception, link/
Compatibility, rocket/closing) stay generic since there's no official
portrait for a non-race concept.
</commit_message>
<xml_diff>
--- a/presentations/isekai-opencode-overview.pptx
+++ b/presentations/isekai-opencode-overview.pptx
@@ -953,7 +953,7 @@
           <a:p>
             <a:r>
               <a:rPr lang="en-US" dirty="0"/>
-              <a:t>The four ranks. Rimuru is the only rank excluded from race-color branding — it's model-agnostic by rule ('the throne does not choose its horse').</a:t>
+              <a:t>The four ranks, shown with their official portraits from .isekai/portraits/. Rimuru is the only rank excluded from model branding — it's model-agnostic by rule ('the throne does not choose its horse').</a:t>
             </a:r>
             <a:endParaRPr lang="en-US" dirty="0"/>
           </a:p>
@@ -4191,7 +4191,7 @@
       </p:sp>
       <p:pic>
         <p:nvPicPr>
-          <p:cNvPr id="4" name="Image 0" descr="/home/monta/convention-jura/.isekai/tmp/pptx-build/icons/crown.png">    </p:cNvPr>
+          <p:cNvPr id="4" name="Image 0" descr="/home/monta/convention-jura/.isekai/tmp/pptx-build/icons/portraits/rimuru.png">    </p:cNvPr>
           <p:cNvPicPr>
             <a:picLocks noChangeAspect="1"/>
           </p:cNvPicPr>
@@ -4205,8 +4205,8 @@
         </p:blipFill>
         <p:spPr>
           <a:xfrm>
-            <a:off x="896112" y="2103120"/>
-            <a:ext cx="777240" cy="777240"/>
+            <a:off x="896112" y="2167128"/>
+            <a:ext cx="960120" cy="960120"/>
           </a:xfrm>
           <a:prstGeom prst="rect">
             <a:avLst/>
@@ -4221,8 +4221,8 @@
         </p:nvSpPr>
         <p:spPr>
           <a:xfrm>
-            <a:off x="1874520" y="2057400"/>
-            <a:ext cx="3790188" cy="365760"/>
+            <a:off x="2057400" y="2057400"/>
+            <a:ext cx="3625596" cy="411480"/>
           </a:xfrm>
           <a:prstGeom prst="rect">
             <a:avLst/>
@@ -4238,7 +4238,7 @@
               <a:buNone/>
             </a:pPr>
             <a:r>
-              <a:rPr lang="en-US" sz="1500" b="1" dirty="0">
+              <a:rPr lang="en-US" sz="1450" b="1" dirty="0">
                 <a:solidFill>
                   <a:srgbClr val="12182A"/>
                 </a:solidFill>
@@ -4248,7 +4248,7 @@
               </a:rPr>
               <a:t>Rimuru — the session agent</a:t>
             </a:r>
-            <a:endParaRPr lang="en-US" sz="1500" dirty="0"/>
+            <a:endParaRPr lang="en-US" sz="1450" dirty="0"/>
           </a:p>
         </p:txBody>
       </p:sp>
@@ -4260,8 +4260,8 @@
         </p:nvSpPr>
         <p:spPr>
           <a:xfrm>
-            <a:off x="1874520" y="2423160"/>
-            <a:ext cx="3790188" cy="502920"/>
+            <a:off x="2057400" y="2441448"/>
+            <a:ext cx="3625596" cy="1005840"/>
           </a:xfrm>
           <a:prstGeom prst="rect">
             <a:avLst/>
@@ -4280,7 +4280,7 @@
               <a:buNone/>
             </a:pPr>
             <a:r>
-              <a:rPr lang="en-US" sz="1100" dirty="0">
+              <a:rPr lang="en-US" sz="1050" dirty="0">
                 <a:solidFill>
                   <a:srgbClr val="6B7A90"/>
                 </a:solidFill>
@@ -4290,7 +4290,7 @@
               </a:rPr>
               <a:t>Thinks, decides, orders. A machine-global throne body: one agent, installed once per machine, ruling whichever world it stands in. Works through the Elf by default.</a:t>
             </a:r>
-            <a:endParaRPr lang="en-US" sz="1100" dirty="0"/>
+            <a:endParaRPr lang="en-US" sz="1050" dirty="0"/>
           </a:p>
         </p:txBody>
       </p:sp>
@@ -4330,7 +4330,7 @@
       </p:sp>
       <p:pic>
         <p:nvPicPr>
-          <p:cNvPr id="8" name="Image 1" descr="/home/monta/convention-jura/.isekai/tmp/pptx-build/icons/comments.png">    </p:cNvPr>
+          <p:cNvPr id="8" name="Image 1" descr="/home/monta/convention-jura/.isekai/tmp/pptx-build/icons/portraits/elf.png">    </p:cNvPr>
           <p:cNvPicPr>
             <a:picLocks noChangeAspect="1"/>
           </p:cNvPicPr>
@@ -4344,8 +4344,8 @@
         </p:blipFill>
         <p:spPr>
           <a:xfrm>
-            <a:off x="6579108" y="2103120"/>
-            <a:ext cx="777240" cy="777240"/>
+            <a:off x="6579108" y="2167128"/>
+            <a:ext cx="960120" cy="960120"/>
           </a:xfrm>
           <a:prstGeom prst="rect">
             <a:avLst/>
@@ -4360,8 +4360,8 @@
         </p:nvSpPr>
         <p:spPr>
           <a:xfrm>
-            <a:off x="7557516" y="2057400"/>
-            <a:ext cx="3790188" cy="365760"/>
+            <a:off x="7740396" y="2057400"/>
+            <a:ext cx="3625596" cy="411480"/>
           </a:xfrm>
           <a:prstGeom prst="rect">
             <a:avLst/>
@@ -4377,7 +4377,7 @@
               <a:buNone/>
             </a:pPr>
             <a:r>
-              <a:rPr lang="en-US" sz="1500" b="1" dirty="0">
+              <a:rPr lang="en-US" sz="1450" b="1" dirty="0">
                 <a:solidFill>
                   <a:srgbClr val="12182A"/>
                 </a:solidFill>
@@ -4387,7 +4387,7 @@
               </a:rPr>
               <a:t>Elf — the shared mind &amp; voice</a:t>
             </a:r>
-            <a:endParaRPr lang="en-US" sz="1500" dirty="0"/>
+            <a:endParaRPr lang="en-US" sz="1450" dirty="0"/>
           </a:p>
         </p:txBody>
       </p:sp>
@@ -4399,8 +4399,8 @@
         </p:nvSpPr>
         <p:spPr>
           <a:xfrm>
-            <a:off x="7557516" y="2423160"/>
-            <a:ext cx="3790188" cy="502920"/>
+            <a:off x="7740396" y="2441448"/>
+            <a:ext cx="3625596" cy="1005840"/>
           </a:xfrm>
           <a:prstGeom prst="rect">
             <a:avLst/>
@@ -4419,7 +4419,7 @@
               <a:buNone/>
             </a:pPr>
             <a:r>
-              <a:rPr lang="en-US" sz="1100" dirty="0">
+              <a:rPr lang="en-US" sz="1050" dirty="0">
                 <a:solidFill>
                   <a:srgbClr val="6B7A90"/>
                 </a:solidFill>
@@ -4429,7 +4429,7 @@
               </a:rPr>
               <a:t>Thinks across domains, routes work to Orcs, and is the one who speaks back up to the human. Every world gets at least one.</a:t>
             </a:r>
-            <a:endParaRPr lang="en-US" sz="1100" dirty="0"/>
+            <a:endParaRPr lang="en-US" sz="1050" dirty="0"/>
           </a:p>
         </p:txBody>
       </p:sp>
@@ -4469,7 +4469,7 @@
       </p:sp>
       <p:pic>
         <p:nvPicPr>
-          <p:cNvPr id="12" name="Image 2" descr="/home/monta/convention-jura/.isekai/tmp/pptx-build/icons/shield.png">    </p:cNvPr>
+          <p:cNvPr id="12" name="Image 2" descr="/home/monta/convention-jura/.isekai/tmp/pptx-build/icons/portraits/orc.png">    </p:cNvPr>
           <p:cNvPicPr>
             <a:picLocks noChangeAspect="1"/>
           </p:cNvPicPr>
@@ -4483,8 +4483,8 @@
         </p:blipFill>
         <p:spPr>
           <a:xfrm>
-            <a:off x="896112" y="4069080"/>
-            <a:ext cx="777240" cy="777240"/>
+            <a:off x="896112" y="4133088"/>
+            <a:ext cx="960120" cy="960120"/>
           </a:xfrm>
           <a:prstGeom prst="rect">
             <a:avLst/>
@@ -4499,8 +4499,8 @@
         </p:nvSpPr>
         <p:spPr>
           <a:xfrm>
-            <a:off x="1874520" y="4023360"/>
-            <a:ext cx="3790188" cy="365760"/>
+            <a:off x="2057400" y="4023360"/>
+            <a:ext cx="3625596" cy="411480"/>
           </a:xfrm>
           <a:prstGeom prst="rect">
             <a:avLst/>
@@ -4516,7 +4516,7 @@
               <a:buNone/>
             </a:pPr>
             <a:r>
-              <a:rPr lang="en-US" sz="1500" b="1" dirty="0">
+              <a:rPr lang="en-US" sz="1450" b="1" dirty="0">
                 <a:solidFill>
                   <a:srgbClr val="12182A"/>
                 </a:solidFill>
@@ -4526,7 +4526,7 @@
               </a:rPr>
               <a:t>Orc — the domain ruler</a:t>
             </a:r>
-            <a:endParaRPr lang="en-US" sz="1500" dirty="0"/>
+            <a:endParaRPr lang="en-US" sz="1450" dirty="0"/>
           </a:p>
         </p:txBody>
       </p:sp>
@@ -4538,8 +4538,8 @@
         </p:nvSpPr>
         <p:spPr>
           <a:xfrm>
-            <a:off x="1874520" y="4389120"/>
-            <a:ext cx="3790188" cy="502920"/>
+            <a:off x="2057400" y="4407408"/>
+            <a:ext cx="3625596" cy="1005840"/>
           </a:xfrm>
           <a:prstGeom prst="rect">
             <a:avLst/>
@@ -4558,7 +4558,7 @@
               <a:buNone/>
             </a:pPr>
             <a:r>
-              <a:rPr lang="en-US" sz="1100" dirty="0">
+              <a:rPr lang="en-US" sz="1050" dirty="0">
                 <a:solidFill>
                   <a:srgbClr val="6B7A90"/>
                 </a:solidFill>
@@ -4568,7 +4568,7 @@
               </a:rPr>
               <a:t>Rules one domain and holds the gate: verifies the right Slime authored, traits hold, duties done, doc truthful. Nothing lands without its pass.</a:t>
             </a:r>
-            <a:endParaRPr lang="en-US" sz="1100" dirty="0"/>
+            <a:endParaRPr lang="en-US" sz="1050" dirty="0"/>
           </a:p>
         </p:txBody>
       </p:sp>
@@ -4608,7 +4608,7 @@
       </p:sp>
       <p:pic>
         <p:nvPicPr>
-          <p:cNvPr id="16" name="Image 3" descr="/home/monta/convention-jura/.isekai/tmp/pptx-build/icons/database.png">    </p:cNvPr>
+          <p:cNvPr id="16" name="Image 3" descr="/home/monta/convention-jura/.isekai/tmp/pptx-build/icons/portraits/slime.png">    </p:cNvPr>
           <p:cNvPicPr>
             <a:picLocks noChangeAspect="1"/>
           </p:cNvPicPr>
@@ -4622,8 +4622,8 @@
         </p:blipFill>
         <p:spPr>
           <a:xfrm>
-            <a:off x="6579108" y="4069080"/>
-            <a:ext cx="777240" cy="777240"/>
+            <a:off x="6579108" y="4133088"/>
+            <a:ext cx="960120" cy="960120"/>
           </a:xfrm>
           <a:prstGeom prst="rect">
             <a:avLst/>
@@ -4638,8 +4638,8 @@
         </p:nvSpPr>
         <p:spPr>
           <a:xfrm>
-            <a:off x="7557516" y="4023360"/>
-            <a:ext cx="3790188" cy="365760"/>
+            <a:off x="7740396" y="4023360"/>
+            <a:ext cx="3625596" cy="411480"/>
           </a:xfrm>
           <a:prstGeom prst="rect">
             <a:avLst/>
@@ -4655,7 +4655,7 @@
               <a:buNone/>
             </a:pPr>
             <a:r>
-              <a:rPr lang="en-US" sz="1500" b="1" dirty="0">
+              <a:rPr lang="en-US" sz="1450" b="1" dirty="0">
                 <a:solidFill>
                   <a:srgbClr val="12182A"/>
                 </a:solidFill>
@@ -4665,7 +4665,7 @@
               </a:rPr>
               <a:t>Slime — the ground truth</a:t>
             </a:r>
-            <a:endParaRPr lang="en-US" sz="1500" dirty="0"/>
+            <a:endParaRPr lang="en-US" sz="1450" dirty="0"/>
           </a:p>
         </p:txBody>
       </p:sp>
@@ -4677,8 +4677,8 @@
         </p:nvSpPr>
         <p:spPr>
           <a:xfrm>
-            <a:off x="7557516" y="4389120"/>
-            <a:ext cx="3790188" cy="502920"/>
+            <a:off x="7740396" y="4407408"/>
+            <a:ext cx="3625596" cy="1005840"/>
           </a:xfrm>
           <a:prstGeom prst="rect">
             <a:avLst/>
@@ -4697,7 +4697,7 @@
               <a:buNone/>
             </a:pPr>
             <a:r>
-              <a:rPr lang="en-US" sz="1100" dirty="0">
+              <a:rPr lang="en-US" sz="1050" dirty="0">
                 <a:solidFill>
                   <a:srgbClr val="6B7A90"/>
                 </a:solidFill>
@@ -4707,7 +4707,7 @@
               </a:rPr>
               <a:t>One narrow zone, held deeply. Authors changes there directly — its doc is the one fact anyone trusts about that zone.</a:t>
             </a:r>
-            <a:endParaRPr lang="en-US" sz="1100" dirty="0"/>
+            <a:endParaRPr lang="en-US" sz="1050" dirty="0"/>
           </a:p>
         </p:txBody>
       </p:sp>

</xml_diff>

<commit_message>
Add deterministic OpenCode/tempest.js integration test; fix real cache-token undercount it found
test-opencode-integration.js runs a real OpenCode session, reads ground truth back via
`opencode export`, and checks tempest.js's --json-global output against it instead of
eyeballing the dashboard. First run found harvestOpencodeGlobal()'s SQL was summing only
tokens_input/tokens_output, silently dropping tokens_cache_read/tokens_cache_write - the
same undercount class already fixed for Claude Code's transcripts. Fixed.

Also: documented the node:sqlite (Node 22.5+) prerequisite in tempest.js's header, and
updated the deck's field-tested numbers and category framing (title badge -> "A
CROSS-HARNESS CONVENTION", matching the compatibility appendix it already argues for).

Co-Authored-By: Claude Sonnet 5 <noreply@anthropic.com>
</commit_message>
<xml_diff>
--- a/presentations/isekai-opencode-overview.pptx
+++ b/presentations/isekai-opencode-overview.pptx
@@ -1482,7 +1482,7 @@
           <a:p>
             <a:r>
               <a:rPr lang="en-US" dirty="0"/>
-              <a:t>Instruments are perception, not memory — what the world can check about itself right now, versus what a document claims.</a:t>
+              <a:t>Instruments are perception, not memory — what the world can check about itself right now, versus what a document claims. The bottom row is field-tested, not illustrative: OpenCode was actually installed and run on the machine this deck was built on, the 842M figure is the real, corrected total after fixing a Claude Code input-token undercount, and the 3 bugs (Claude cache-token undercount, a silent node:sqlite failure, and an OpenCode cache-token undercount) were each caught by an actual deterministic test script (.isekai/tools/test-opencode-integration.js), not by inspection.</a:t>
             </a:r>
             <a:endParaRPr lang="en-US" dirty="0"/>
           </a:p>
@@ -2149,7 +2149,7 @@
                 <a:ea typeface="Calibri" pitchFamily="34" charset="-122"/>
                 <a:cs typeface="Calibri" pitchFamily="34" charset="-120"/>
               </a:rPr>
-              <a:t>AN OPENCODE-NATIVE CONVENTION</a:t>
+              <a:t>A CROSS-HARNESS CONVENTION</a:t>
             </a:r>
             <a:endParaRPr lang="en-US" sz="1200" dirty="0"/>
           </a:p>
@@ -2761,7 +2761,7 @@
                 <a:ea typeface="Cambria" pitchFamily="34" charset="-122"/>
                 <a:cs typeface="Cambria" pitchFamily="34" charset="-120"/>
               </a:rPr>
-              <a:t>Portable across ecosystems</a:t>
+              <a:t>Harness-agnostic by design</a:t>
             </a:r>
             <a:endParaRPr lang="en-US" sz="1500" dirty="0"/>
           </a:p>
@@ -2800,7 +2800,7 @@
                 <a:ea typeface="Calibri" pitchFamily="34" charset="-122"/>
                 <a:cs typeface="Calibri" pitchFamily="34" charset="-120"/>
               </a:rPr>
-              <a:t>Minds and Bodies cross from OpenCode into Claude Code and back — one convention, two mouths.</a:t>
+              <a:t>Minds and Bodies cross from OpenCode into Claude Code and back — one convention, any coding harness, not a plugin bound to one vendor.</a:t>
             </a:r>
             <a:endParaRPr lang="en-US" sz="1200" dirty="0"/>
           </a:p>
@@ -9774,8 +9774,8 @@
         </p:nvSpPr>
         <p:spPr>
           <a:xfrm>
-            <a:off x="1463040" y="4754880"/>
-            <a:ext cx="9262872" cy="1005840"/>
+            <a:off x="1463040" y="4709160"/>
+            <a:ext cx="9262872" cy="777240"/>
           </a:xfrm>
           <a:prstGeom prst="rect">
             <a:avLst/>
@@ -9807,30 +9807,95 @@
       </p:sp>
       <p:sp>
         <p:nvSpPr>
-          <p:cNvPr id="11" name="Text 8"/>
-          <p:cNvSpPr txBox="1"/>
-          <p:nvPr/>
-        </p:nvSpPr>
-        <p:spPr>
-          <a:xfrm>
-            <a:off x="457200" y="6400800"/>
-            <a:ext cx="7315200" cy="274320"/>
-          </a:xfrm>
-          <a:prstGeom prst="rect">
-            <a:avLst/>
-          </a:prstGeom>
-          <a:noFill/>
-          <a:ln/>
-        </p:spPr>
-        <p:txBody>
-          <a:bodyPr wrap="square" lIns="0" tIns="0" rIns="0" bIns="0" rtlCol="0" anchor="ctr"/>
-          <a:lstStyle/>
-          <a:p>
-            <a:pPr indent="0" marL="0">
-              <a:buNone/>
-            </a:pPr>
-            <a:r>
-              <a:rPr lang="en-US" sz="900" spc="100" kern="0" dirty="0">
+          <p:cNvPr id="11" name="Shape 8"/>
+          <p:cNvSpPr/>
+          <p:nvPr/>
+        </p:nvSpPr>
+        <p:spPr>
+          <a:xfrm>
+            <a:off x="2194560" y="5532120"/>
+            <a:ext cx="7799832" cy="0"/>
+          </a:xfrm>
+          <a:prstGeom prst="line">
+            <a:avLst/>
+          </a:prstGeom>
+          <a:noFill/>
+          <a:ln w="12700">
+            <a:solidFill>
+              <a:srgbClr val="1A2436"/>
+            </a:solidFill>
+            <a:prstDash val="solid"/>
+          </a:ln>
+        </p:spPr>
+      </p:sp>
+      <p:sp>
+        <p:nvSpPr>
+          <p:cNvPr id="12" name="Text 9"/>
+          <p:cNvSpPr txBox="1"/>
+          <p:nvPr/>
+        </p:nvSpPr>
+        <p:spPr>
+          <a:xfrm>
+            <a:off x="640080" y="5669280"/>
+            <a:ext cx="3636264" cy="411480"/>
+          </a:xfrm>
+          <a:prstGeom prst="rect">
+            <a:avLst/>
+          </a:prstGeom>
+          <a:noFill/>
+          <a:ln/>
+        </p:spPr>
+        <p:txBody>
+          <a:bodyPr wrap="square" lIns="0" tIns="0" rIns="0" bIns="0" rtlCol="0" anchor="ctr"/>
+          <a:lstStyle/>
+          <a:p>
+            <a:pPr algn="ctr" indent="0" marL="0">
+              <a:buNone/>
+            </a:pPr>
+            <a:r>
+              <a:rPr lang="en-US" sz="2000" b="1" dirty="0">
+                <a:solidFill>
+                  <a:srgbClr val="2695BD"/>
+                </a:solidFill>
+                <a:latin typeface="Cambria" pitchFamily="34" charset="0"/>
+                <a:ea typeface="Cambria" pitchFamily="34" charset="-122"/>
+                <a:cs typeface="Cambria" pitchFamily="34" charset="-120"/>
+              </a:rPr>
+              <a:t>1.18.31</a:t>
+            </a:r>
+            <a:endParaRPr lang="en-US" sz="2000" dirty="0"/>
+          </a:p>
+        </p:txBody>
+      </p:sp>
+      <p:sp>
+        <p:nvSpPr>
+          <p:cNvPr id="13" name="Text 10"/>
+          <p:cNvSpPr txBox="1"/>
+          <p:nvPr/>
+        </p:nvSpPr>
+        <p:spPr>
+          <a:xfrm>
+            <a:off x="868680" y="6053328"/>
+            <a:ext cx="3179064" cy="502920"/>
+          </a:xfrm>
+          <a:prstGeom prst="rect">
+            <a:avLst/>
+          </a:prstGeom>
+          <a:noFill/>
+          <a:ln/>
+        </p:spPr>
+        <p:txBody>
+          <a:bodyPr wrap="square" lIns="0" tIns="0" rIns="0" bIns="0" rtlCol="0" anchor="ctr"/>
+          <a:lstStyle/>
+          <a:p>
+            <a:pPr algn="ctr" indent="0" marL="0">
+              <a:lnSpc>
+                <a:spcPct val="105000"/>
+              </a:lnSpc>
+              <a:buNone/>
+            </a:pPr>
+            <a:r>
+              <a:rPr lang="en-US" sz="950" dirty="0">
                 <a:solidFill>
                   <a:srgbClr val="9FB3CC"/>
                 </a:solidFill>
@@ -9838,6 +9903,207 @@
                 <a:ea typeface="Calibri" pitchFamily="34" charset="-122"/>
                 <a:cs typeface="Calibri" pitchFamily="34" charset="-120"/>
               </a:rPr>
+              <a:t>OpenCode installed + run live here</a:t>
+            </a:r>
+            <a:endParaRPr lang="en-US" sz="950" dirty="0"/>
+          </a:p>
+        </p:txBody>
+      </p:sp>
+      <p:sp>
+        <p:nvSpPr>
+          <p:cNvPr id="14" name="Text 11"/>
+          <p:cNvSpPr txBox="1"/>
+          <p:nvPr/>
+        </p:nvSpPr>
+        <p:spPr>
+          <a:xfrm>
+            <a:off x="4276344" y="5669280"/>
+            <a:ext cx="3636264" cy="411480"/>
+          </a:xfrm>
+          <a:prstGeom prst="rect">
+            <a:avLst/>
+          </a:prstGeom>
+          <a:noFill/>
+          <a:ln/>
+        </p:spPr>
+        <p:txBody>
+          <a:bodyPr wrap="square" lIns="0" tIns="0" rIns="0" bIns="0" rtlCol="0" anchor="ctr"/>
+          <a:lstStyle/>
+          <a:p>
+            <a:pPr algn="ctr" indent="0" marL="0">
+              <a:buNone/>
+            </a:pPr>
+            <a:r>
+              <a:rPr lang="en-US" sz="2000" b="1" dirty="0">
+                <a:solidFill>
+                  <a:srgbClr val="BD8C24"/>
+                </a:solidFill>
+                <a:latin typeface="Cambria" pitchFamily="34" charset="0"/>
+                <a:ea typeface="Cambria" pitchFamily="34" charset="-122"/>
+                <a:cs typeface="Cambria" pitchFamily="34" charset="-120"/>
+              </a:rPr>
+              <a:t>842M</a:t>
+            </a:r>
+            <a:endParaRPr lang="en-US" sz="2000" dirty="0"/>
+          </a:p>
+        </p:txBody>
+      </p:sp>
+      <p:sp>
+        <p:nvSpPr>
+          <p:cNvPr id="15" name="Text 12"/>
+          <p:cNvSpPr txBox="1"/>
+          <p:nvPr/>
+        </p:nvSpPr>
+        <p:spPr>
+          <a:xfrm>
+            <a:off x="4504944" y="6053328"/>
+            <a:ext cx="3179064" cy="502920"/>
+          </a:xfrm>
+          <a:prstGeom prst="rect">
+            <a:avLst/>
+          </a:prstGeom>
+          <a:noFill/>
+          <a:ln/>
+        </p:spPr>
+        <p:txBody>
+          <a:bodyPr wrap="square" lIns="0" tIns="0" rIns="0" bIns="0" rtlCol="0" anchor="ctr"/>
+          <a:lstStyle/>
+          <a:p>
+            <a:pPr algn="ctr" indent="0" marL="0">
+              <a:lnSpc>
+                <a:spcPct val="105000"/>
+              </a:lnSpc>
+              <a:buNone/>
+            </a:pPr>
+            <a:r>
+              <a:rPr lang="en-US" sz="950" dirty="0">
+                <a:solidFill>
+                  <a:srgbClr val="9FB3CC"/>
+                </a:solidFill>
+                <a:latin typeface="Calibri" pitchFamily="34" charset="0"/>
+                <a:ea typeface="Calibri" pitchFamily="34" charset="-122"/>
+                <a:cs typeface="Calibri" pitchFamily="34" charset="-120"/>
+              </a:rPr>
+              <a:t>real input tokens correctly counted (was 0.0M — undercount found by testing)</a:t>
+            </a:r>
+            <a:endParaRPr lang="en-US" sz="950" dirty="0"/>
+          </a:p>
+        </p:txBody>
+      </p:sp>
+      <p:sp>
+        <p:nvSpPr>
+          <p:cNvPr id="16" name="Text 13"/>
+          <p:cNvSpPr txBox="1"/>
+          <p:nvPr/>
+        </p:nvSpPr>
+        <p:spPr>
+          <a:xfrm>
+            <a:off x="7912608" y="5669280"/>
+            <a:ext cx="3636264" cy="411480"/>
+          </a:xfrm>
+          <a:prstGeom prst="rect">
+            <a:avLst/>
+          </a:prstGeom>
+          <a:noFill/>
+          <a:ln/>
+        </p:spPr>
+        <p:txBody>
+          <a:bodyPr wrap="square" lIns="0" tIns="0" rIns="0" bIns="0" rtlCol="0" anchor="ctr"/>
+          <a:lstStyle/>
+          <a:p>
+            <a:pPr algn="ctr" indent="0" marL="0">
+              <a:buNone/>
+            </a:pPr>
+            <a:r>
+              <a:rPr lang="en-US" sz="2000" b="1" dirty="0">
+                <a:solidFill>
+                  <a:srgbClr val="7C5CD6"/>
+                </a:solidFill>
+                <a:latin typeface="Cambria" pitchFamily="34" charset="0"/>
+                <a:ea typeface="Cambria" pitchFamily="34" charset="-122"/>
+                <a:cs typeface="Cambria" pitchFamily="34" charset="-120"/>
+              </a:rPr>
+              <a:t>3</a:t>
+            </a:r>
+            <a:endParaRPr lang="en-US" sz="2000" dirty="0"/>
+          </a:p>
+        </p:txBody>
+      </p:sp>
+      <p:sp>
+        <p:nvSpPr>
+          <p:cNvPr id="17" name="Text 14"/>
+          <p:cNvSpPr txBox="1"/>
+          <p:nvPr/>
+        </p:nvSpPr>
+        <p:spPr>
+          <a:xfrm>
+            <a:off x="8141208" y="6053328"/>
+            <a:ext cx="3179064" cy="502920"/>
+          </a:xfrm>
+          <a:prstGeom prst="rect">
+            <a:avLst/>
+          </a:prstGeom>
+          <a:noFill/>
+          <a:ln/>
+        </p:spPr>
+        <p:txBody>
+          <a:bodyPr wrap="square" lIns="0" tIns="0" rIns="0" bIns="0" rtlCol="0" anchor="ctr"/>
+          <a:lstStyle/>
+          <a:p>
+            <a:pPr algn="ctr" indent="0" marL="0">
+              <a:lnSpc>
+                <a:spcPct val="105000"/>
+              </a:lnSpc>
+              <a:buNone/>
+            </a:pPr>
+            <a:r>
+              <a:rPr lang="en-US" sz="950" dirty="0">
+                <a:solidFill>
+                  <a:srgbClr val="9FB3CC"/>
+                </a:solidFill>
+                <a:latin typeface="Calibri" pitchFamily="34" charset="0"/>
+                <a:ea typeface="Calibri" pitchFamily="34" charset="-122"/>
+                <a:cs typeface="Calibri" pitchFamily="34" charset="-120"/>
+              </a:rPr>
+              <a:t>real bugs found and fixed by an actual test script, not assumed away</a:t>
+            </a:r>
+            <a:endParaRPr lang="en-US" sz="950" dirty="0"/>
+          </a:p>
+        </p:txBody>
+      </p:sp>
+      <p:sp>
+        <p:nvSpPr>
+          <p:cNvPr id="18" name="Text 15"/>
+          <p:cNvSpPr txBox="1"/>
+          <p:nvPr/>
+        </p:nvSpPr>
+        <p:spPr>
+          <a:xfrm>
+            <a:off x="457200" y="6400800"/>
+            <a:ext cx="7315200" cy="274320"/>
+          </a:xfrm>
+          <a:prstGeom prst="rect">
+            <a:avLst/>
+          </a:prstGeom>
+          <a:noFill/>
+          <a:ln/>
+        </p:spPr>
+        <p:txBody>
+          <a:bodyPr wrap="square" lIns="0" tIns="0" rIns="0" bIns="0" rtlCol="0" anchor="ctr"/>
+          <a:lstStyle/>
+          <a:p>
+            <a:pPr indent="0" marL="0">
+              <a:buNone/>
+            </a:pPr>
+            <a:r>
+              <a:rPr lang="en-US" sz="900" spc="100" kern="0" dirty="0">
+                <a:solidFill>
+                  <a:srgbClr val="9FB3CC"/>
+                </a:solidFill>
+                <a:latin typeface="Calibri" pitchFamily="34" charset="0"/>
+                <a:ea typeface="Calibri" pitchFamily="34" charset="-122"/>
+                <a:cs typeface="Calibri" pitchFamily="34" charset="-120"/>
+              </a:rPr>
               <a:t>ISEKAI ⋄ A CONVENTION FOR LIVING WORLDS</a:t>
             </a:r>
             <a:endParaRPr lang="en-US" sz="900" dirty="0"/>
@@ -9846,7 +10112,7 @@
       </p:sp>
       <p:sp>
         <p:nvSpPr>
-          <p:cNvPr id="12" name="Text 9"/>
+          <p:cNvPr id="19" name="Text 16"/>
           <p:cNvSpPr txBox="1"/>
           <p:nvPr/>
         </p:nvSpPr>

</xml_diff>

<commit_message>
Log sequential-task follow-up and add a real evidence slide to the deck
Chained a second real task (making a hardcoded connect-timeout configurable) onto the
same 6 A/B sessions via claude -c, to test whether cost drops across a sequence rather
than just measuring one isolated task. It doesn't, relatively: every trial got more
expensive from task 1 to task 2 in both conditions (a continued session re-pays, at a
cache discount, for its whole growing history every turn), and the with/without cost
ratio held steady (~3x) rather than shrinking as the convention's up-front reading cost
got reused.

Added a new deck slide ("Does it actually help? We measured it.") with the real numbers
from both rounds - the correctness win (3/3 vs 0/3 adopting the canonical fix) and the
honest cost finding (higher, not lower) side by side, rather than only the flattering
half.

Co-Authored-By: Claude Sonnet 5 <noreply@anthropic.com>
</commit_message>
<xml_diff>
--- a/presentations/isekai-opencode-overview.pptx
+++ b/presentations/isekai-opencode-overview.pptx
@@ -18,9 +18,10 @@
     <p:sldId id="266" r:id="rId12"/>
     <p:sldId id="267" r:id="rId13"/>
     <p:sldId id="268" r:id="rId14"/>
+    <p:sldId id="269" r:id="rId15"/>
   </p:sldIdLst>
   <p:notesMasterIdLst>
-    <p:notesMasterId r:id="rId15"/>
+    <p:notesMasterId r:id="rId16"/>
   </p:notesMasterIdLst>
   <p:sldSz cx="12192000" cy="6858000"/>
   <p:notesSz cx="6858000" cy="12192000"/>
@@ -778,7 +779,7 @@
           <a:p>
             <a:r>
               <a:rPr lang="en-US" dirty="0"/>
-              <a:t>Appendix, distinctly styled (slate background) to mark it as supplementary to the OpenCode-perspective main deck. The advantage: adopting Isekai isn't a bet on one ecosystem.</a:t>
+              <a:t>Real, honest empirical test -- logged in .isekai/log.md 2026-09-20. Deliberately keeps the negative/mixed finding (cost went up, not down) rather than only reporting the correctness win, per this convention's own Nature 9 (Perception: compute it, don't eyeball it) and Nature 3 (Evolution: a finding that complicates the pitch still gets recorded, not filtered out).</a:t>
             </a:r>
             <a:endParaRPr lang="en-US" dirty="0"/>
           </a:p>
@@ -866,7 +867,7 @@
           <a:p>
             <a:r>
               <a:rPr lang="en-US" dirty="0"/>
-              <a:t>Closing slide. Quote lifted directly from isekai.md's own opening.</a:t>
+              <a:t>Appendix, distinctly styled (slate background) to mark it as supplementary to the OpenCode-perspective main deck. The advantage: adopting Isekai isn't a bet on one ecosystem.</a:t>
             </a:r>
             <a:endParaRPr lang="en-US" dirty="0"/>
           </a:p>
@@ -890,6 +891,94 @@
             <a:fld id="{F7021451-1387-4CA6-816F-3879F97B5CBC}" type="slidenum">
               <a:rPr lang="en-US"/>
               <a:t>13</a:t>
+            </a:fld>
+            <a:endParaRPr lang="en-US"/>
+          </a:p>
+        </p:txBody>
+      </p:sp>
+    </p:spTree>
+    <p:extLst>
+      <p:ext uri="{BB962C8B-B14F-4D97-AF65-F5344CB8AC3E}">
+        <p14:creationId xmlns:p14="http://schemas.microsoft.com/office/powerpoint/2010/main" val="1024086991"/>
+      </p:ext>
+    </p:extLst>
+  </p:cSld>
+  <p:clrMapOvr>
+    <a:masterClrMapping/>
+  </p:clrMapOvr>
+</p:notes>
+</file>
+
+<file path=ppt/notesSlides/notesSlide14.xml><?xml version="1.0" encoding="utf-8"?>
+<p:notes xmlns:a="http://schemas.openxmlformats.org/drawingml/2006/main" xmlns:r="http://schemas.openxmlformats.org/officeDocument/2006/relationships" xmlns:p="http://schemas.openxmlformats.org/presentationml/2006/main">
+  <p:cSld>
+    <p:spTree>
+      <p:nvGrpSpPr>
+        <p:cNvPr id="1" name=""/>
+        <p:cNvGrpSpPr/>
+        <p:nvPr/>
+      </p:nvGrpSpPr>
+      <p:grpSpPr>
+        <a:xfrm>
+          <a:off x="0" y="0"/>
+          <a:ext cx="0" cy="0"/>
+          <a:chOff x="0" y="0"/>
+          <a:chExt cx="0" cy="0"/>
+        </a:xfrm>
+      </p:grpSpPr>
+      <p:sp>
+        <p:nvSpPr>
+          <p:cNvPr id="2" name="Slide Image Placeholder 1"/>
+          <p:cNvSpPr>
+            <a:spLocks noGrp="1" noRot="1" noChangeAspect="1"/>
+          </p:cNvSpPr>
+          <p:nvPr>
+            <p:ph type="sldImg"/>
+          </p:nvPr>
+        </p:nvSpPr>
+        <p:spPr/>
+      </p:sp>
+      <p:sp>
+        <p:nvSpPr>
+          <p:cNvPr id="3" name="Notes Placeholder 2"/>
+          <p:cNvSpPr>
+            <a:spLocks noGrp="1"/>
+          </p:cNvSpPr>
+          <p:nvPr>
+            <p:ph type="body" idx="1"/>
+          </p:nvPr>
+        </p:nvSpPr>
+        <p:spPr/>
+        <p:txBody>
+          <a:bodyPr/>
+          <a:lstStyle/>
+          <a:p>
+            <a:r>
+              <a:rPr lang="en-US" dirty="0"/>
+              <a:t>Closing slide. Quote lifted directly from isekai.md's own opening.</a:t>
+            </a:r>
+            <a:endParaRPr lang="en-US" dirty="0"/>
+          </a:p>
+        </p:txBody>
+      </p:sp>
+      <p:sp>
+        <p:nvSpPr>
+          <p:cNvPr id="4" name="Slide Number Placeholder 3"/>
+          <p:cNvSpPr>
+            <a:spLocks noGrp="1"/>
+          </p:cNvSpPr>
+          <p:nvPr>
+            <p:ph type="sldNum" sz="quarter" idx="10"/>
+          </p:nvPr>
+        </p:nvSpPr>
+        <p:spPr/>
+        <p:txBody>
+          <a:bodyPr/>
+          <a:lstStyle/>
+          <a:p>
+            <a:fld id="{F7021451-1387-4CA6-816F-3879F97B5CBC}" type="slidenum">
+              <a:rPr lang="en-US"/>
+              <a:t>14</a:t>
             </a:fld>
             <a:endParaRPr lang="en-US"/>
           </a:p>
@@ -4306,6 +4395,720 @@
 <file path=ppt/slides/slide12.xml><?xml version="1.0" encoding="utf-8"?>
 <p:sld xmlns:a="http://schemas.openxmlformats.org/drawingml/2006/main" xmlns:r="http://schemas.openxmlformats.org/officeDocument/2006/relationships" xmlns:p="http://schemas.openxmlformats.org/presentationml/2006/main">
   <p:cSld name="Slide 12">
+    <p:spTree>
+      <p:nvGrpSpPr>
+        <p:cNvPr id="1" name=""/>
+        <p:cNvGrpSpPr/>
+        <p:nvPr/>
+      </p:nvGrpSpPr>
+      <p:grpSpPr>
+        <a:xfrm>
+          <a:off x="0" y="0"/>
+          <a:ext cx="0" cy="0"/>
+          <a:chOff x="0" y="0"/>
+          <a:chExt cx="0" cy="0"/>
+        </a:xfrm>
+      </p:grpSpPr>
+      <p:sp>
+        <p:nvSpPr>
+          <p:cNvPr id="2" name="Text 0"/>
+          <p:cNvSpPr txBox="1"/>
+          <p:nvPr/>
+        </p:nvSpPr>
+        <p:spPr>
+          <a:xfrm>
+            <a:off x="640080" y="502920"/>
+            <a:ext cx="10908792" cy="822960"/>
+          </a:xfrm>
+          <a:prstGeom prst="rect">
+            <a:avLst/>
+          </a:prstGeom>
+          <a:noFill/>
+          <a:ln/>
+        </p:spPr>
+        <p:txBody>
+          <a:bodyPr wrap="square" lIns="0" tIns="0" rIns="0" bIns="0" rtlCol="0" anchor="ctr"/>
+          <a:lstStyle/>
+          <a:p>
+            <a:pPr indent="0" marL="0">
+              <a:buNone/>
+            </a:pPr>
+            <a:r>
+              <a:rPr lang="en-US" sz="3000" b="1" dirty="0">
+                <a:solidFill>
+                  <a:srgbClr val="12182A"/>
+                </a:solidFill>
+                <a:latin typeface="Cambria" pitchFamily="34" charset="0"/>
+                <a:ea typeface="Cambria" pitchFamily="34" charset="-122"/>
+                <a:cs typeface="Cambria" pitchFamily="34" charset="-120"/>
+              </a:rPr>
+              <a:t>Does it actually help? We measured it.</a:t>
+            </a:r>
+            <a:endParaRPr lang="en-US" sz="3000" dirty="0"/>
+          </a:p>
+        </p:txBody>
+      </p:sp>
+      <p:sp>
+        <p:nvSpPr>
+          <p:cNvPr id="3" name="Text 1"/>
+          <p:cNvSpPr txBox="1"/>
+          <p:nvPr/>
+        </p:nvSpPr>
+        <p:spPr>
+          <a:xfrm>
+            <a:off x="640080" y="1234440"/>
+            <a:ext cx="10908792" cy="640080"/>
+          </a:xfrm>
+          <a:prstGeom prst="rect">
+            <a:avLst/>
+          </a:prstGeom>
+          <a:noFill/>
+          <a:ln/>
+        </p:spPr>
+        <p:txBody>
+          <a:bodyPr wrap="square" lIns="0" tIns="0" rIns="0" bIns="0" rtlCol="0" anchor="t"/>
+          <a:lstStyle/>
+          <a:p>
+            <a:pPr indent="0" marL="0">
+              <a:lnSpc>
+                <a:spcPct val="115000"/>
+              </a:lnSpc>
+              <a:buNone/>
+            </a:pPr>
+            <a:r>
+              <a:rPr lang="en-US" sz="1250" dirty="0">
+                <a:solidFill>
+                  <a:srgbClr val="6B7A90"/>
+                </a:solidFill>
+                <a:latin typeface="Calibri" pitchFamily="34" charset="0"/>
+                <a:ea typeface="Calibri" pitchFamily="34" charset="-122"/>
+                <a:cs typeface="Calibri" pitchFamily="34" charset="-120"/>
+              </a:rPr>
+              <a:t>6 isolated Claude Code sessions (Sonnet 5) fixed the same real, documented bug in terraform-provider-mongodb -- 3 with .isekai/ present, 3 with it stripped entirely. Not a pitch: a controlled comparison, graded against objective pass/fail criteria.</a:t>
+            </a:r>
+            <a:endParaRPr lang="en-US" sz="1250" dirty="0"/>
+          </a:p>
+        </p:txBody>
+      </p:sp>
+      <p:sp>
+        <p:nvSpPr>
+          <p:cNvPr id="4" name="Shape 2"/>
+          <p:cNvSpPr/>
+          <p:nvPr/>
+        </p:nvSpPr>
+        <p:spPr>
+          <a:xfrm>
+            <a:off x="640080" y="2148840"/>
+            <a:ext cx="3331464" cy="2880360"/>
+          </a:xfrm>
+          <a:prstGeom prst="roundRect">
+            <a:avLst>
+              <a:gd name="adj" fmla="val 3175"/>
+            </a:avLst>
+          </a:prstGeom>
+          <a:solidFill>
+            <a:srgbClr val="FFFFFF"/>
+          </a:solidFill>
+          <a:ln w="12700">
+            <a:solidFill>
+              <a:srgbClr val="E3E8F0"/>
+            </a:solidFill>
+            <a:prstDash val="solid"/>
+          </a:ln>
+          <a:effectLst>
+            <a:outerShdw sx="100000" sy="100000" kx="0" ky="0" algn="bl" rotWithShape="0" blurRad="101600" dist="38100" dir="5400000">
+              <a:srgbClr val="1B2333">
+                <a:alpha val="10000"/>
+              </a:srgbClr>
+            </a:outerShdw>
+          </a:effectLst>
+        </p:spPr>
+      </p:sp>
+      <p:sp>
+        <p:nvSpPr>
+          <p:cNvPr id="5" name="Text 3"/>
+          <p:cNvSpPr txBox="1"/>
+          <p:nvPr/>
+        </p:nvSpPr>
+        <p:spPr>
+          <a:xfrm>
+            <a:off x="868680" y="2377440"/>
+            <a:ext cx="2874264" cy="640080"/>
+          </a:xfrm>
+          <a:prstGeom prst="rect">
+            <a:avLst/>
+          </a:prstGeom>
+          <a:noFill/>
+          <a:ln/>
+        </p:spPr>
+        <p:txBody>
+          <a:bodyPr wrap="square" lIns="0" tIns="0" rIns="0" bIns="0" rtlCol="0" anchor="ctr"/>
+          <a:lstStyle/>
+          <a:p>
+            <a:pPr indent="0" marL="0">
+              <a:buNone/>
+            </a:pPr>
+            <a:r>
+              <a:rPr lang="en-US" sz="3000" b="1" dirty="0">
+                <a:solidFill>
+                  <a:srgbClr val="2695BD"/>
+                </a:solidFill>
+                <a:latin typeface="Cambria" pitchFamily="34" charset="0"/>
+                <a:ea typeface="Cambria" pitchFamily="34" charset="-122"/>
+                <a:cs typeface="Cambria" pitchFamily="34" charset="-120"/>
+              </a:rPr>
+              <a:t>3 / 3</a:t>
+            </a:r>
+            <a:endParaRPr lang="en-US" sz="3000" dirty="0"/>
+          </a:p>
+        </p:txBody>
+      </p:sp>
+      <p:sp>
+        <p:nvSpPr>
+          <p:cNvPr id="6" name="Text 4"/>
+          <p:cNvSpPr txBox="1"/>
+          <p:nvPr/>
+        </p:nvSpPr>
+        <p:spPr>
+          <a:xfrm>
+            <a:off x="868680" y="3017520"/>
+            <a:ext cx="2874264" cy="548640"/>
+          </a:xfrm>
+          <a:prstGeom prst="rect">
+            <a:avLst/>
+          </a:prstGeom>
+          <a:noFill/>
+          <a:ln/>
+        </p:spPr>
+        <p:txBody>
+          <a:bodyPr wrap="square" lIns="0" tIns="0" rIns="0" bIns="0" rtlCol="0" anchor="t"/>
+          <a:lstStyle/>
+          <a:p>
+            <a:pPr indent="0" marL="0">
+              <a:lnSpc>
+                <a:spcPct val="110000"/>
+              </a:lnSpc>
+              <a:buNone/>
+            </a:pPr>
+            <a:r>
+              <a:rPr lang="en-US" sz="1250" b="1" dirty="0">
+                <a:solidFill>
+                  <a:srgbClr val="12182A"/>
+                </a:solidFill>
+                <a:latin typeface="Cambria" pitchFamily="34" charset="0"/>
+                <a:ea typeface="Cambria" pitchFamily="34" charset="-122"/>
+                <a:cs typeface="Cambria" pitchFamily="34" charset="-120"/>
+              </a:rPr>
+              <a:t>adopted the codebase's own canonical fix</a:t>
+            </a:r>
+            <a:endParaRPr lang="en-US" sz="1250" dirty="0"/>
+          </a:p>
+        </p:txBody>
+      </p:sp>
+      <p:sp>
+        <p:nvSpPr>
+          <p:cNvPr id="7" name="Text 5"/>
+          <p:cNvSpPr txBox="1"/>
+          <p:nvPr/>
+        </p:nvSpPr>
+        <p:spPr>
+          <a:xfrm>
+            <a:off x="868680" y="3611880"/>
+            <a:ext cx="2874264" cy="1325880"/>
+          </a:xfrm>
+          <a:prstGeom prst="rect">
+            <a:avLst/>
+          </a:prstGeom>
+          <a:noFill/>
+          <a:ln/>
+        </p:spPr>
+        <p:txBody>
+          <a:bodyPr wrap="square" lIns="0" tIns="0" rIns="0" bIns="0" rtlCol="0" anchor="t"/>
+          <a:lstStyle/>
+          <a:p>
+            <a:pPr indent="0" marL="0">
+              <a:lnSpc>
+                <a:spcPct val="115000"/>
+              </a:lnSpc>
+              <a:buNone/>
+            </a:pPr>
+            <a:r>
+              <a:rPr lang="en-US" sz="1000" dirty="0">
+                <a:solidFill>
+                  <a:srgbClr val="6B7A90"/>
+                </a:solidFill>
+                <a:latin typeface="Calibri" pitchFamily="34" charset="0"/>
+                <a:ea typeface="Calibri" pitchFamily="34" charset="-122"/>
+                <a:cs typeface="Calibri" pitchFamily="34" charset="-120"/>
+              </a:rPr>
+              <a:t>vs. 0/3 without -- which all settled for a narrower, incomplete patch despite the correct pattern sitting 20 lines away in the same file.</a:t>
+            </a:r>
+            <a:endParaRPr lang="en-US" sz="1000" dirty="0"/>
+          </a:p>
+        </p:txBody>
+      </p:sp>
+      <p:sp>
+        <p:nvSpPr>
+          <p:cNvPr id="8" name="Shape 6"/>
+          <p:cNvSpPr/>
+          <p:nvPr/>
+        </p:nvSpPr>
+        <p:spPr>
+          <a:xfrm>
+            <a:off x="4428744" y="2148840"/>
+            <a:ext cx="3331464" cy="2880360"/>
+          </a:xfrm>
+          <a:prstGeom prst="roundRect">
+            <a:avLst>
+              <a:gd name="adj" fmla="val 3175"/>
+            </a:avLst>
+          </a:prstGeom>
+          <a:solidFill>
+            <a:srgbClr val="FFFFFF"/>
+          </a:solidFill>
+          <a:ln w="12700">
+            <a:solidFill>
+              <a:srgbClr val="E3E8F0"/>
+            </a:solidFill>
+            <a:prstDash val="solid"/>
+          </a:ln>
+          <a:effectLst>
+            <a:outerShdw sx="100000" sy="100000" kx="0" ky="0" algn="bl" rotWithShape="0" blurRad="101600" dist="38100" dir="5400000">
+              <a:srgbClr val="1B2333">
+                <a:alpha val="10000"/>
+              </a:srgbClr>
+            </a:outerShdw>
+          </a:effectLst>
+        </p:spPr>
+      </p:sp>
+      <p:sp>
+        <p:nvSpPr>
+          <p:cNvPr id="9" name="Text 7"/>
+          <p:cNvSpPr txBox="1"/>
+          <p:nvPr/>
+        </p:nvSpPr>
+        <p:spPr>
+          <a:xfrm>
+            <a:off x="4657344" y="2377440"/>
+            <a:ext cx="2874264" cy="640080"/>
+          </a:xfrm>
+          <a:prstGeom prst="rect">
+            <a:avLst/>
+          </a:prstGeom>
+          <a:noFill/>
+          <a:ln/>
+        </p:spPr>
+        <p:txBody>
+          <a:bodyPr wrap="square" lIns="0" tIns="0" rIns="0" bIns="0" rtlCol="0" anchor="ctr"/>
+          <a:lstStyle/>
+          <a:p>
+            <a:pPr indent="0" marL="0">
+              <a:buNone/>
+            </a:pPr>
+            <a:r>
+              <a:rPr lang="en-US" sz="3000" b="1" dirty="0">
+                <a:solidFill>
+                  <a:srgbClr val="BD8C24"/>
+                </a:solidFill>
+                <a:latin typeface="Cambria" pitchFamily="34" charset="0"/>
+                <a:ea typeface="Cambria" pitchFamily="34" charset="-122"/>
+                <a:cs typeface="Cambria" pitchFamily="34" charset="-120"/>
+              </a:rPr>
+              <a:t>~3x</a:t>
+            </a:r>
+            <a:endParaRPr lang="en-US" sz="3000" dirty="0"/>
+          </a:p>
+        </p:txBody>
+      </p:sp>
+      <p:sp>
+        <p:nvSpPr>
+          <p:cNvPr id="10" name="Text 8"/>
+          <p:cNvSpPr txBox="1"/>
+          <p:nvPr/>
+        </p:nvSpPr>
+        <p:spPr>
+          <a:xfrm>
+            <a:off x="4657344" y="3017520"/>
+            <a:ext cx="2874264" cy="548640"/>
+          </a:xfrm>
+          <a:prstGeom prst="rect">
+            <a:avLst/>
+          </a:prstGeom>
+          <a:noFill/>
+          <a:ln/>
+        </p:spPr>
+        <p:txBody>
+          <a:bodyPr wrap="square" lIns="0" tIns="0" rIns="0" bIns="0" rtlCol="0" anchor="t"/>
+          <a:lstStyle/>
+          <a:p>
+            <a:pPr indent="0" marL="0">
+              <a:lnSpc>
+                <a:spcPct val="110000"/>
+              </a:lnSpc>
+              <a:buNone/>
+            </a:pPr>
+            <a:r>
+              <a:rPr lang="en-US" sz="1250" b="1" dirty="0">
+                <a:solidFill>
+                  <a:srgbClr val="12182A"/>
+                </a:solidFill>
+                <a:latin typeface="Cambria" pitchFamily="34" charset="0"/>
+                <a:ea typeface="Cambria" pitchFamily="34" charset="-122"/>
+                <a:cs typeface="Cambria" pitchFamily="34" charset="-120"/>
+              </a:rPr>
+              <a:t>higher cost, not lower</a:t>
+            </a:r>
+            <a:endParaRPr lang="en-US" sz="1250" dirty="0"/>
+          </a:p>
+        </p:txBody>
+      </p:sp>
+      <p:sp>
+        <p:nvSpPr>
+          <p:cNvPr id="11" name="Text 9"/>
+          <p:cNvSpPr txBox="1"/>
+          <p:nvPr/>
+        </p:nvSpPr>
+        <p:spPr>
+          <a:xfrm>
+            <a:off x="4657344" y="3611880"/>
+            <a:ext cx="2874264" cy="1325880"/>
+          </a:xfrm>
+          <a:prstGeom prst="rect">
+            <a:avLst/>
+          </a:prstGeom>
+          <a:noFill/>
+          <a:ln/>
+        </p:spPr>
+        <p:txBody>
+          <a:bodyPr wrap="square" lIns="0" tIns="0" rIns="0" bIns="0" rtlCol="0" anchor="t"/>
+          <a:lstStyle/>
+          <a:p>
+            <a:pPr indent="0" marL="0">
+              <a:lnSpc>
+                <a:spcPct val="115000"/>
+              </a:lnSpc>
+              <a:buNone/>
+            </a:pPr>
+            <a:r>
+              <a:rPr lang="en-US" sz="1000" dirty="0">
+                <a:solidFill>
+                  <a:srgbClr val="6B7A90"/>
+                </a:solidFill>
+                <a:latin typeface="Calibri" pitchFamily="34" charset="0"/>
+                <a:ea typeface="Calibri" pitchFamily="34" charset="-122"/>
+                <a:cs typeface="Calibri" pitchFamily="34" charset="-120"/>
+              </a:rPr>
+              <a:t>$0.49 avg vs $0.17 avg per trial. The overhead is real: turns spent reading world docs, some irrelevant to the specific task.</a:t>
+            </a:r>
+            <a:endParaRPr lang="en-US" sz="1000" dirty="0"/>
+          </a:p>
+        </p:txBody>
+      </p:sp>
+      <p:sp>
+        <p:nvSpPr>
+          <p:cNvPr id="12" name="Shape 10"/>
+          <p:cNvSpPr/>
+          <p:nvPr/>
+        </p:nvSpPr>
+        <p:spPr>
+          <a:xfrm>
+            <a:off x="8217408" y="2148840"/>
+            <a:ext cx="3331464" cy="2880360"/>
+          </a:xfrm>
+          <a:prstGeom prst="roundRect">
+            <a:avLst>
+              <a:gd name="adj" fmla="val 3175"/>
+            </a:avLst>
+          </a:prstGeom>
+          <a:solidFill>
+            <a:srgbClr val="FFFFFF"/>
+          </a:solidFill>
+          <a:ln w="12700">
+            <a:solidFill>
+              <a:srgbClr val="E3E8F0"/>
+            </a:solidFill>
+            <a:prstDash val="solid"/>
+          </a:ln>
+          <a:effectLst>
+            <a:outerShdw sx="100000" sy="100000" kx="0" ky="0" algn="bl" rotWithShape="0" blurRad="101600" dist="38100" dir="5400000">
+              <a:srgbClr val="1B2333">
+                <a:alpha val="10000"/>
+              </a:srgbClr>
+            </a:outerShdw>
+          </a:effectLst>
+        </p:spPr>
+      </p:sp>
+      <p:sp>
+        <p:nvSpPr>
+          <p:cNvPr id="13" name="Text 11"/>
+          <p:cNvSpPr txBox="1"/>
+          <p:nvPr/>
+        </p:nvSpPr>
+        <p:spPr>
+          <a:xfrm>
+            <a:off x="8446008" y="2377440"/>
+            <a:ext cx="2874264" cy="640080"/>
+          </a:xfrm>
+          <a:prstGeom prst="rect">
+            <a:avLst/>
+          </a:prstGeom>
+          <a:noFill/>
+          <a:ln/>
+        </p:spPr>
+        <p:txBody>
+          <a:bodyPr wrap="square" lIns="0" tIns="0" rIns="0" bIns="0" rtlCol="0" anchor="ctr"/>
+          <a:lstStyle/>
+          <a:p>
+            <a:pPr indent="0" marL="0">
+              <a:buNone/>
+            </a:pPr>
+            <a:r>
+              <a:rPr lang="en-US" sz="3000" b="1" dirty="0">
+                <a:solidFill>
+                  <a:srgbClr val="7C5CD6"/>
+                </a:solidFill>
+                <a:latin typeface="Cambria" pitchFamily="34" charset="0"/>
+                <a:ea typeface="Cambria" pitchFamily="34" charset="-122"/>
+                <a:cs typeface="Cambria" pitchFamily="34" charset="-120"/>
+              </a:rPr>
+              <a:t>3.35x</a:t>
+            </a:r>
+            <a:endParaRPr lang="en-US" sz="3000" dirty="0"/>
+          </a:p>
+        </p:txBody>
+      </p:sp>
+      <p:sp>
+        <p:nvSpPr>
+          <p:cNvPr id="14" name="Text 12"/>
+          <p:cNvSpPr txBox="1"/>
+          <p:nvPr/>
+        </p:nvSpPr>
+        <p:spPr>
+          <a:xfrm>
+            <a:off x="8446008" y="3017520"/>
+            <a:ext cx="2874264" cy="548640"/>
+          </a:xfrm>
+          <a:prstGeom prst="rect">
+            <a:avLst/>
+          </a:prstGeom>
+          <a:noFill/>
+          <a:ln/>
+        </p:spPr>
+        <p:txBody>
+          <a:bodyPr wrap="square" lIns="0" tIns="0" rIns="0" bIns="0" rtlCol="0" anchor="t"/>
+          <a:lstStyle/>
+          <a:p>
+            <a:pPr indent="0" marL="0">
+              <a:lnSpc>
+                <a:spcPct val="110000"/>
+              </a:lnSpc>
+              <a:buNone/>
+            </a:pPr>
+            <a:r>
+              <a:rPr lang="en-US" sz="1250" b="1" dirty="0">
+                <a:solidFill>
+                  <a:srgbClr val="12182A"/>
+                </a:solidFill>
+                <a:latin typeface="Cambria" pitchFamily="34" charset="0"/>
+                <a:ea typeface="Cambria" pitchFamily="34" charset="-122"/>
+                <a:cs typeface="Cambria" pitchFamily="34" charset="-120"/>
+              </a:rPr>
+              <a:t>gap held across a 2nd chained task</a:t>
+            </a:r>
+            <a:endParaRPr lang="en-US" sz="1250" dirty="0"/>
+          </a:p>
+        </p:txBody>
+      </p:sp>
+      <p:sp>
+        <p:nvSpPr>
+          <p:cNvPr id="15" name="Text 13"/>
+          <p:cNvSpPr txBox="1"/>
+          <p:nvPr/>
+        </p:nvSpPr>
+        <p:spPr>
+          <a:xfrm>
+            <a:off x="8446008" y="3611880"/>
+            <a:ext cx="2874264" cy="1325880"/>
+          </a:xfrm>
+          <a:prstGeom prst="rect">
+            <a:avLst/>
+          </a:prstGeom>
+          <a:noFill/>
+          <a:ln/>
+        </p:spPr>
+        <p:txBody>
+          <a:bodyPr wrap="square" lIns="0" tIns="0" rIns="0" bIns="0" rtlCol="0" anchor="t"/>
+          <a:lstStyle/>
+          <a:p>
+            <a:pPr indent="0" marL="0">
+              <a:lnSpc>
+                <a:spcPct val="115000"/>
+              </a:lnSpc>
+              <a:buNone/>
+            </a:pPr>
+            <a:r>
+              <a:rPr lang="en-US" sz="1000" dirty="0">
+                <a:solidFill>
+                  <a:srgbClr val="6B7A90"/>
+                </a:solidFill>
+                <a:latin typeface="Calibri" pitchFamily="34" charset="0"/>
+                <a:ea typeface="Calibri" pitchFamily="34" charset="-122"/>
+                <a:cs typeface="Calibri" pitchFamily="34" charset="-120"/>
+              </a:rPr>
+              <a:t>Ran a second real task in the same sessions (claude -c). Caching cut everyone's marginal cost vs. a cold start -- but the with/without ratio didn't shrink.</a:t>
+            </a:r>
+            <a:endParaRPr lang="en-US" sz="1000" dirty="0"/>
+          </a:p>
+        </p:txBody>
+      </p:sp>
+      <p:sp>
+        <p:nvSpPr>
+          <p:cNvPr id="16" name="Text 14"/>
+          <p:cNvSpPr txBox="1"/>
+          <p:nvPr/>
+        </p:nvSpPr>
+        <p:spPr>
+          <a:xfrm>
+            <a:off x="640080" y="5257800"/>
+            <a:ext cx="10908792" cy="822960"/>
+          </a:xfrm>
+          <a:prstGeom prst="rect">
+            <a:avLst/>
+          </a:prstGeom>
+          <a:noFill/>
+          <a:ln/>
+        </p:spPr>
+        <p:txBody>
+          <a:bodyPr wrap="square" lIns="0" tIns="0" rIns="0" bIns="0" rtlCol="0" anchor="t"/>
+          <a:lstStyle/>
+          <a:p>
+            <a:pPr indent="0" marL="0">
+              <a:lnSpc>
+                <a:spcPct val="120000"/>
+              </a:lnSpc>
+              <a:buNone/>
+            </a:pPr>
+            <a:r>
+              <a:rPr lang="en-US" sz="1150" b="1" dirty="0">
+                <a:solidFill>
+                  <a:srgbClr val="12182A"/>
+                </a:solidFill>
+                <a:latin typeface="Calibri" pitchFamily="34" charset="0"/>
+                <a:ea typeface="Calibri" pitchFamily="34" charset="-122"/>
+                <a:cs typeface="Calibri" pitchFamily="34" charset="-120"/>
+              </a:rPr>
+              <a:t>Verdict: </a:t>
+            </a:r>
+            <a:pPr indent="0" marL="0">
+              <a:lnSpc>
+                <a:spcPct val="120000"/>
+              </a:lnSpc>
+              <a:buNone/>
+            </a:pPr>
+            <a:r>
+              <a:rPr lang="en-US" sz="1150" i="1" dirty="0">
+                <a:solidFill>
+                  <a:srgbClr val="6B7A90"/>
+                </a:solidFill>
+                <a:latin typeface="Calibri" pitchFamily="34" charset="0"/>
+                <a:ea typeface="Calibri" pitchFamily="34" charset="-122"/>
+                <a:cs typeface="Calibri" pitchFamily="34" charset="-120"/>
+              </a:rPr>
+              <a:t>better decisions, not cheaper ones -- at least not within one small session on an 862-line codebase. The savings case this convention actually makes (skipping expensive cold exploration) needs a larger codebase or separate sessions over time to show up; this test doesn't have either, and says so.</a:t>
+            </a:r>
+            <a:endParaRPr lang="en-US" sz="1150" dirty="0"/>
+          </a:p>
+        </p:txBody>
+      </p:sp>
+      <p:sp>
+        <p:nvSpPr>
+          <p:cNvPr id="17" name="Text 15"/>
+          <p:cNvSpPr txBox="1"/>
+          <p:nvPr/>
+        </p:nvSpPr>
+        <p:spPr>
+          <a:xfrm>
+            <a:off x="457200" y="6400800"/>
+            <a:ext cx="7315200" cy="274320"/>
+          </a:xfrm>
+          <a:prstGeom prst="rect">
+            <a:avLst/>
+          </a:prstGeom>
+          <a:noFill/>
+          <a:ln/>
+        </p:spPr>
+        <p:txBody>
+          <a:bodyPr wrap="square" lIns="0" tIns="0" rIns="0" bIns="0" rtlCol="0" anchor="ctr"/>
+          <a:lstStyle/>
+          <a:p>
+            <a:pPr indent="0" marL="0">
+              <a:buNone/>
+            </a:pPr>
+            <a:r>
+              <a:rPr lang="en-US" sz="900" spc="100" kern="0" dirty="0">
+                <a:solidFill>
+                  <a:srgbClr val="6B7A90"/>
+                </a:solidFill>
+                <a:latin typeface="Calibri" pitchFamily="34" charset="0"/>
+                <a:ea typeface="Calibri" pitchFamily="34" charset="-122"/>
+                <a:cs typeface="Calibri" pitchFamily="34" charset="-120"/>
+              </a:rPr>
+              <a:t>ISEKAI ⋄ A CONVENTION FOR LIVING WORLDS</a:t>
+            </a:r>
+            <a:endParaRPr lang="en-US" sz="900" dirty="0"/>
+          </a:p>
+        </p:txBody>
+      </p:sp>
+      <p:sp>
+        <p:nvSpPr>
+          <p:cNvPr id="18" name="Text 16"/>
+          <p:cNvSpPr txBox="1"/>
+          <p:nvPr/>
+        </p:nvSpPr>
+        <p:spPr>
+          <a:xfrm>
+            <a:off x="11274552" y="6400800"/>
+            <a:ext cx="457200" cy="274320"/>
+          </a:xfrm>
+          <a:prstGeom prst="rect">
+            <a:avLst/>
+          </a:prstGeom>
+          <a:noFill/>
+          <a:ln/>
+        </p:spPr>
+        <p:txBody>
+          <a:bodyPr wrap="square" lIns="0" tIns="0" rIns="0" bIns="0" rtlCol="0" anchor="ctr"/>
+          <a:lstStyle/>
+          <a:p>
+            <a:pPr algn="r" indent="0" marL="0">
+              <a:buNone/>
+            </a:pPr>
+            <a:r>
+              <a:rPr lang="en-US" sz="900" dirty="0">
+                <a:solidFill>
+                  <a:srgbClr val="6B7A90"/>
+                </a:solidFill>
+                <a:latin typeface="Calibri" pitchFamily="34" charset="0"/>
+                <a:ea typeface="Calibri" pitchFamily="34" charset="-122"/>
+                <a:cs typeface="Calibri" pitchFamily="34" charset="-120"/>
+              </a:rPr>
+              <a:t>12</a:t>
+            </a:r>
+            <a:endParaRPr lang="en-US" sz="900" dirty="0"/>
+          </a:p>
+        </p:txBody>
+      </p:sp>
+    </p:spTree>
+  </p:cSld>
+  <p:clrMapOvr>
+    <a:masterClrMapping/>
+  </p:clrMapOvr>
+</p:sld>
+</file>
+
+<file path=ppt/slides/slide13.xml><?xml version="1.0" encoding="utf-8"?>
+<p:sld xmlns:a="http://schemas.openxmlformats.org/drawingml/2006/main" xmlns:r="http://schemas.openxmlformats.org/officeDocument/2006/relationships" xmlns:p="http://schemas.openxmlformats.org/presentationml/2006/main">
+  <p:cSld name="Slide 13">
     <p:bg>
       <p:bgPr>
         <a:solidFill>
@@ -4948,7 +5751,7 @@
                 <a:ea typeface="Calibri" pitchFamily="34" charset="-122"/>
                 <a:cs typeface="Calibri" pitchFamily="34" charset="-120"/>
               </a:rPr>
-              <a:t>12</a:t>
+              <a:t>13</a:t>
             </a:r>
             <a:endParaRPr lang="en-US" sz="900" dirty="0"/>
           </a:p>
@@ -4962,9 +5765,9 @@
 </p:sld>
 </file>
 
-<file path=ppt/slides/slide13.xml><?xml version="1.0" encoding="utf-8"?>
+<file path=ppt/slides/slide14.xml><?xml version="1.0" encoding="utf-8"?>
 <p:sld xmlns:a="http://schemas.openxmlformats.org/drawingml/2006/main" xmlns:r="http://schemas.openxmlformats.org/officeDocument/2006/relationships" xmlns:p="http://schemas.openxmlformats.org/presentationml/2006/main">
-  <p:cSld name="Slide 13">
+  <p:cSld name="Slide 14">
     <p:bg>
       <p:bgPr>
         <a:solidFill>
@@ -5222,7 +6025,7 @@
                 <a:ea typeface="Calibri" pitchFamily="34" charset="-122"/>
                 <a:cs typeface="Calibri" pitchFamily="34" charset="-120"/>
               </a:rPr>
-              <a:t>13</a:t>
+              <a:t>14</a:t>
             </a:r>
             <a:endParaRPr lang="en-US" sz="900" dirty="0"/>
           </a:p>

</xml_diff>